<commit_message>
Set the metasurface gap to 2 mm; assign presenters; slide tweaks
- Gap changed from 3.9 mm to 2 mm everywhere: literature.py (GAP_MM),
  report, deck (text, table, gap chart), speaker script, stack-up
  diagram, literature summary; derived wavelength fractions recomputed.
- Gap-phase chart handles small gaps (a metal plate stays outside the
  ±90° window over the whole plotted band at 2 mm).
- Deck: "WORK DONE" labels removed from the results slides; challenges
  slide retitled "What were the challenges, and what comes next".
- Script: presenters set by the team: Anushka (slides 1-4),
  Nishit (5-8), Chanswarang (9-12), Sanjana (13-15).

Co-Authored-By: Claude Opus 5.5 <noreply@anthropic.com>
Claude-Session: https://claude.ai/code/session_01418gBW7bQ3FVSGE7vGQMYY
</commit_message>
<xml_diff>
--- a/presentation/FYP_Presentation.pptx
+++ b/presentation/FYP_Presentation.pptx
@@ -184,7 +184,7 @@
           </c:spPr>
           <c:invertIfNegative val="0"/>
           <c:dLbls>
-            <c:numFmt formatCode="0.0" sourceLinked="0"/>
+            <c:numFmt formatCode="0" sourceLinked="0"/>
             <c:txPr>
               <a:bodyPr/>
               <a:lstStyle/>
@@ -294,7 +294,7 @@
                 <c:formatCode>General</c:formatCode>
                 <c:ptCount val="5"/>
                 <c:pt idx="0">
-                  <c:v>3.9</c:v>
+                  <c:v>2</c:v>
                 </c:pt>
                 <c:pt idx="1">
                   <c:v>9</c:v>
@@ -313,7 +313,7 @@
           </c:val>
         </c:ser>
         <c:dLbls>
-          <c:numFmt formatCode="0.0" sourceLinked="0"/>
+          <c:numFmt formatCode="0" sourceLinked="0"/>
           <c:txPr>
             <a:bodyPr/>
             <a:lstStyle/>
@@ -1195,7 +1195,7 @@
           <a:p>
             <a:r>
               <a:rPr lang="en-US" dirty="0"/>
-              <a:t>Top: the antenna alone. Bottom: the same antenna with the metasurface 3.9 millimetres behind it, on the same frequency axis. The band now starts lower, at about 2 GHz, and stays matched up to 18 GHz — the end of our simulation. But there are three narrow regions, shaded red, where S11 rises above minus 10 dB, the worst being minus 6.6 dB near 3.1 GHz. At such a small gap the metasurface also changes the antenna's input match, so it needs tuning. We do not have the gain result yet; that is the next simulation.</a:t>
+              <a:t>Top: the antenna alone. Bottom: the same antenna with the metasurface 2 millimetres behind it, on the same frequency axis. The band now starts lower, at about 2 GHz, and stays matched up to 18 GHz — the end of our simulation. But there are three narrow regions, shaded red, where S11 rises above minus 10 dB, the worst being minus 6.6 dB near 3.1 GHz. At such a small gap the metasurface also changes the antenna's input match, so it needs tuning. We do not have the gain result yet; that is the next simulation.</a:t>
             </a:r>
             <a:endParaRPr lang="en-US" dirty="0"/>
           </a:p>
@@ -1811,7 +1811,7 @@
           <a:p>
             <a:r>
               <a:rPr lang="en-US" dirty="0"/>
-              <a:t>A metasurface is a thin board printed with many small, repeated metal cells. Each of our cells has two split rings: a ring with a small cut behaves like a tiny resonant circuit, and two rings of different size give two resonances. The board has solid copper on the back and sits only 3.9 millimetres behind the antenna. The copper reflects the backward wave and the rings shift how it reflects, so that it can add to the forward wave instead of cancelling it. Whether the gain really rises is what our next simulation will show.</a:t>
+              <a:t>A metasurface is a thin board printed with many small, repeated metal cells. Each of our cells has two split rings: a ring with a small cut behaves like a tiny resonant circuit, and two rings of different size give two resonances. The board has solid copper on the back and sits only 2 millimetres behind the antenna. The copper reflects the backward wave and the rings shift how it reflects, so that it can add to the forward wave instead of cancelling it. Whether the gain really rises is what our next simulation will show.</a:t>
             </a:r>
             <a:endParaRPr lang="en-US" dirty="0"/>
           </a:p>
@@ -1987,7 +1987,7 @@
           <a:p>
             <a:r>
               <a:rPr lang="en-US" dirty="0"/>
-              <a:t>We reviewed ten papers; here are the closest five. Reflectors behind wideband antennas raise the gain by about 4 to 6 dB. But as the chart shows, most of them sit 9 to 20 millimetres behind the antenna. Our metasurface sits only 3.9 millimetres behind. A gap this thin over a band as wide as 2 to 15 GHz is rarely reported — that is our research gap.</a:t>
+              <a:t>We reviewed ten papers; here are the closest five. Reflectors behind wideband antennas raise the gain by about 4 to 6 dB. But as the chart shows, most of them sit 9 to 20 millimetres behind the antenna. Our metasurface sits only 2 millimetres behind. A gap this thin over a band as wide as 2 to 15 GHz is rarely reported — that is our research gap.</a:t>
             </a:r>
             <a:endParaRPr lang="en-US" dirty="0"/>
           </a:p>
@@ -3478,47 +3478,6 @@
           <p:cNvPr id="2" name="Text 0"/>
           <p:cNvSpPr/>
           <p:nvPr>
-            <p:ph idx="100" type="body" hasCustomPrompt="1"/>
-          </p:nvPr>
-        </p:nvSpPr>
-        <p:spPr>
-          <a:xfrm>
-            <a:off x="548640" y="347472"/>
-            <a:ext cx="8229600" cy="292608"/>
-          </a:xfrm>
-          <a:prstGeom prst="rect">
-            <a:avLst/>
-          </a:prstGeom>
-          <a:noFill/>
-          <a:ln/>
-        </p:spPr>
-        <p:txBody>
-          <a:bodyPr wrap="square" lIns="0" tIns="0" rIns="0" bIns="0" rtlCol="0" anchor="ctr"/>
-          <a:lstStyle/>
-          <a:p>
-            <a:pPr indent="0" marL="0">
-              <a:buNone/>
-            </a:pPr>
-            <a:r>
-              <a:rPr lang="en-US" sz="1300" b="1" spc="150" kern="0" dirty="0">
-                <a:solidFill>
-                  <a:srgbClr val="B8651B"/>
-                </a:solidFill>
-                <a:latin typeface="Calibri" pitchFamily="34" charset="0"/>
-                <a:ea typeface="Calibri" pitchFamily="34" charset="-122"/>
-                <a:cs typeface="Calibri" pitchFamily="34" charset="-120"/>
-              </a:rPr>
-              <a:t>WORK DONE · 1</a:t>
-            </a:r>
-            <a:endParaRPr lang="en-US" sz="1300" dirty="0"/>
-          </a:p>
-        </p:txBody>
-      </p:sp>
-      <p:sp>
-        <p:nvSpPr>
-          <p:cNvPr id="3" name="Text 0"/>
-          <p:cNvSpPr/>
-          <p:nvPr>
             <p:ph idx="101" type="title" hasCustomPrompt="1"/>
           </p:nvPr>
         </p:nvSpPr>
@@ -3557,7 +3516,7 @@
       </p:sp>
       <p:sp>
         <p:nvSpPr>
-          <p:cNvPr id="5" name="Shape 2"/>
+          <p:cNvPr id="4" name="Shape 1"/>
           <p:cNvSpPr/>
           <p:nvPr/>
         </p:nvSpPr>
@@ -3579,7 +3538,7 @@
       </p:sp>
       <p:pic>
         <p:nvPicPr>
-          <p:cNvPr id="6" name="cst_initial_antenna.png" descr="/home/user/fyp-mimo-antenna-metasurface/figures/cst_initial_antenna.png">    </p:cNvPr>
+          <p:cNvPr id="5" name="cst_initial_antenna.png" descr="/home/user/fyp-mimo-antenna-metasurface/figures/cst_initial_antenna.png">    </p:cNvPr>
           <p:cNvPicPr>
             <a:picLocks noChangeAspect="1"/>
           </p:cNvPicPr>
@@ -3603,88 +3562,88 @@
       </p:pic>
       <p:sp>
         <p:nvSpPr>
+          <p:cNvPr id="6" name="Text 2"/>
+          <p:cNvSpPr txBox="1"/>
+          <p:nvPr/>
+        </p:nvSpPr>
+        <p:spPr>
+          <a:xfrm>
+            <a:off x="731520" y="4754880"/>
+            <a:ext cx="3063240" cy="594360"/>
+          </a:xfrm>
+          <a:prstGeom prst="rect">
+            <a:avLst/>
+          </a:prstGeom>
+          <a:noFill/>
+          <a:ln/>
+        </p:spPr>
+        <p:txBody>
+          <a:bodyPr wrap="square" lIns="0" tIns="0" rIns="0" bIns="0" rtlCol="0" anchor="t"/>
+          <a:lstStyle/>
+          <a:p>
+            <a:pPr algn="ctr" indent="0" marL="0">
+              <a:lnSpc>
+                <a:spcPct val="100000"/>
+              </a:lnSpc>
+              <a:buNone/>
+            </a:pPr>
+            <a:r>
+              <a:rPr lang="en-US" sz="1400" dirty="0">
+                <a:solidFill>
+                  <a:srgbClr val="5B6472"/>
+                </a:solidFill>
+                <a:latin typeface="Calibri" pitchFamily="34" charset="0"/>
+                <a:ea typeface="Calibri" pitchFamily="34" charset="-122"/>
+                <a:cs typeface="Calibri" pitchFamily="34" charset="-120"/>
+              </a:rPr>
+              <a:t>Initial design: ground far from the patch (L</a:t>
+            </a:r>
+            <a:pPr algn="ctr" indent="0" marL="0">
+              <a:lnSpc>
+                <a:spcPct val="100000"/>
+              </a:lnSpc>
+              <a:buNone/>
+            </a:pPr>
+            <a:r>
+              <a:rPr lang="en-US" sz="1400" baseline="-40000" dirty="0">
+                <a:solidFill>
+                  <a:srgbClr val="5B6472"/>
+                </a:solidFill>
+                <a:latin typeface="Calibri" pitchFamily="34" charset="0"/>
+                <a:ea typeface="Calibri" pitchFamily="34" charset="-122"/>
+                <a:cs typeface="Calibri" pitchFamily="34" charset="-120"/>
+              </a:rPr>
+              <a:t>g</a:t>
+            </a:r>
+            <a:pPr algn="ctr" indent="0" marL="0">
+              <a:lnSpc>
+                <a:spcPct val="100000"/>
+              </a:lnSpc>
+              <a:buNone/>
+            </a:pPr>
+            <a:r>
+              <a:rPr lang="en-US" sz="1400" dirty="0">
+                <a:solidFill>
+                  <a:srgbClr val="5B6472"/>
+                </a:solidFill>
+                <a:latin typeface="Calibri" pitchFamily="34" charset="0"/>
+                <a:ea typeface="Calibri" pitchFamily="34" charset="-122"/>
+                <a:cs typeface="Calibri" pitchFamily="34" charset="-120"/>
+              </a:rPr>
+              <a:t> = −20 mm)</a:t>
+            </a:r>
+            <a:endParaRPr lang="en-US" sz="1400" dirty="0"/>
+          </a:p>
+        </p:txBody>
+      </p:sp>
+      <p:sp>
+        <p:nvSpPr>
           <p:cNvPr id="7" name="Text 3"/>
           <p:cNvSpPr txBox="1"/>
           <p:nvPr/>
         </p:nvSpPr>
         <p:spPr>
           <a:xfrm>
-            <a:off x="731520" y="4754880"/>
-            <a:ext cx="3063240" cy="594360"/>
-          </a:xfrm>
-          <a:prstGeom prst="rect">
-            <a:avLst/>
-          </a:prstGeom>
-          <a:noFill/>
-          <a:ln/>
-        </p:spPr>
-        <p:txBody>
-          <a:bodyPr wrap="square" lIns="0" tIns="0" rIns="0" bIns="0" rtlCol="0" anchor="t"/>
-          <a:lstStyle/>
-          <a:p>
-            <a:pPr algn="ctr" indent="0" marL="0">
-              <a:lnSpc>
-                <a:spcPct val="100000"/>
-              </a:lnSpc>
-              <a:buNone/>
-            </a:pPr>
-            <a:r>
-              <a:rPr lang="en-US" sz="1400" dirty="0">
-                <a:solidFill>
-                  <a:srgbClr val="5B6472"/>
-                </a:solidFill>
-                <a:latin typeface="Calibri" pitchFamily="34" charset="0"/>
-                <a:ea typeface="Calibri" pitchFamily="34" charset="-122"/>
-                <a:cs typeface="Calibri" pitchFamily="34" charset="-120"/>
-              </a:rPr>
-              <a:t>Initial design: ground far from the patch (L</a:t>
-            </a:r>
-            <a:pPr algn="ctr" indent="0" marL="0">
-              <a:lnSpc>
-                <a:spcPct val="100000"/>
-              </a:lnSpc>
-              <a:buNone/>
-            </a:pPr>
-            <a:r>
-              <a:rPr lang="en-US" sz="1400" baseline="-40000" dirty="0">
-                <a:solidFill>
-                  <a:srgbClr val="5B6472"/>
-                </a:solidFill>
-                <a:latin typeface="Calibri" pitchFamily="34" charset="0"/>
-                <a:ea typeface="Calibri" pitchFamily="34" charset="-122"/>
-                <a:cs typeface="Calibri" pitchFamily="34" charset="-120"/>
-              </a:rPr>
-              <a:t>g</a:t>
-            </a:r>
-            <a:pPr algn="ctr" indent="0" marL="0">
-              <a:lnSpc>
-                <a:spcPct val="100000"/>
-              </a:lnSpc>
-              <a:buNone/>
-            </a:pPr>
-            <a:r>
-              <a:rPr lang="en-US" sz="1400" dirty="0">
-                <a:solidFill>
-                  <a:srgbClr val="5B6472"/>
-                </a:solidFill>
-                <a:latin typeface="Calibri" pitchFamily="34" charset="0"/>
-                <a:ea typeface="Calibri" pitchFamily="34" charset="-122"/>
-                <a:cs typeface="Calibri" pitchFamily="34" charset="-120"/>
-              </a:rPr>
-              <a:t> = −20 mm)</a:t>
-            </a:r>
-            <a:endParaRPr lang="en-US" sz="1400" dirty="0"/>
-          </a:p>
-        </p:txBody>
-      </p:sp>
-      <p:sp>
-        <p:nvSpPr>
-          <p:cNvPr id="8" name="Text 4"/>
-          <p:cNvSpPr txBox="1"/>
-          <p:nvPr/>
-        </p:nvSpPr>
-        <p:spPr>
-          <a:xfrm>
             <a:off x="4251960" y="1417320"/>
             <a:ext cx="7391095" cy="320040"/>
           </a:xfrm>
@@ -3755,7 +3714,7 @@
       </p:sp>
       <p:pic>
         <p:nvPicPr>
-          <p:cNvPr id="9" name="cst_initial_ground_s11.png" descr="/home/user/fyp-mimo-antenna-metasurface/presentation/deck/.cache/cst_initial_ground_s11_0_64_2263_959.png">    </p:cNvPr>
+          <p:cNvPr id="8" name="cst_initial_ground_s11.png" descr="/home/user/fyp-mimo-antenna-metasurface/presentation/deck/.cache/cst_initial_ground_s11_0_64_2263_959.png">    </p:cNvPr>
           <p:cNvPicPr>
             <a:picLocks noChangeAspect="1"/>
           </p:cNvPicPr>
@@ -3779,7 +3738,7 @@
       </p:pic>
       <p:sp>
         <p:nvSpPr>
-          <p:cNvPr id="10" name="Shape 5"/>
+          <p:cNvPr id="9" name="Shape 4"/>
           <p:cNvSpPr/>
           <p:nvPr/>
         </p:nvSpPr>
@@ -3801,7 +3760,7 @@
       </p:sp>
       <p:sp>
         <p:nvSpPr>
-          <p:cNvPr id="11" name="Text 6"/>
+          <p:cNvPr id="10" name="Text 5"/>
           <p:cNvSpPr txBox="1"/>
           <p:nvPr/>
         </p:nvSpPr>
@@ -3843,7 +3802,7 @@
       </p:sp>
       <p:sp>
         <p:nvSpPr>
-          <p:cNvPr id="12" name="Shape 7"/>
+          <p:cNvPr id="11" name="Shape 6"/>
           <p:cNvSpPr/>
           <p:nvPr/>
         </p:nvSpPr>
@@ -3865,7 +3824,7 @@
       </p:sp>
       <p:sp>
         <p:nvSpPr>
-          <p:cNvPr id="13" name="Text 8"/>
+          <p:cNvPr id="12" name="Text 7"/>
           <p:cNvSpPr txBox="1"/>
           <p:nvPr/>
         </p:nvSpPr>
@@ -3987,6 +3946,36 @@
               <a:t>not usable yet</a:t>
             </a:r>
             <a:endParaRPr lang="en-US" sz="1600" dirty="0"/>
+          </a:p>
+        </p:txBody>
+      </p:sp>
+      <p:sp>
+        <p:nvSpPr>
+          <p:cNvPr id="13" name="Text 0"/>
+          <p:cNvSpPr/>
+          <p:nvPr>
+            <p:ph idx="100" type="body" hasCustomPrompt="1"/>
+          </p:nvPr>
+        </p:nvSpPr>
+        <p:spPr>
+          <a:xfrm>
+            <a:off x="548640" y="347472"/>
+            <a:ext cx="8229600" cy="292608"/>
+          </a:xfrm>
+          <a:prstGeom prst="rect">
+            <a:avLst/>
+          </a:prstGeom>
+          <a:noFill/>
+          <a:ln/>
+        </p:spPr>
+        <p:txBody>
+          <a:bodyPr wrap="square" lIns="0" tIns="0" rIns="0" bIns="0" rtlCol="0" anchor="ctr"/>
+          <a:lstStyle/>
+          <a:p>
+            <a:pPr indent="0" marL="0">
+              <a:buNone/>
+            </a:pPr>
+            <a:endParaRPr lang="en-US" sz="1300" dirty="0"/>
           </a:p>
         </p:txBody>
       </p:sp>
@@ -4068,47 +4057,6 @@
           <p:cNvPr id="2" name="Text 0"/>
           <p:cNvSpPr/>
           <p:nvPr>
-            <p:ph idx="100" type="body" hasCustomPrompt="1"/>
-          </p:nvPr>
-        </p:nvSpPr>
-        <p:spPr>
-          <a:xfrm>
-            <a:off x="548640" y="347472"/>
-            <a:ext cx="8229600" cy="292608"/>
-          </a:xfrm>
-          <a:prstGeom prst="rect">
-            <a:avLst/>
-          </a:prstGeom>
-          <a:noFill/>
-          <a:ln/>
-        </p:spPr>
-        <p:txBody>
-          <a:bodyPr wrap="square" lIns="0" tIns="0" rIns="0" bIns="0" rtlCol="0" anchor="ctr"/>
-          <a:lstStyle/>
-          <a:p>
-            <a:pPr indent="0" marL="0">
-              <a:buNone/>
-            </a:pPr>
-            <a:r>
-              <a:rPr lang="en-US" sz="1300" b="1" spc="150" kern="0" dirty="0">
-                <a:solidFill>
-                  <a:srgbClr val="B8651B"/>
-                </a:solidFill>
-                <a:latin typeface="Calibri" pitchFamily="34" charset="0"/>
-                <a:ea typeface="Calibri" pitchFamily="34" charset="-122"/>
-                <a:cs typeface="Calibri" pitchFamily="34" charset="-120"/>
-              </a:rPr>
-              <a:t>WORK DONE · 2</a:t>
-            </a:r>
-            <a:endParaRPr lang="en-US" sz="1300" dirty="0"/>
-          </a:p>
-        </p:txBody>
-      </p:sp>
-      <p:sp>
-        <p:nvSpPr>
-          <p:cNvPr id="3" name="Text 0"/>
-          <p:cNvSpPr/>
-          <p:nvPr>
             <p:ph idx="101" type="title" hasCustomPrompt="1"/>
           </p:nvPr>
         </p:nvSpPr>
@@ -4147,7 +4095,7 @@
       </p:sp>
       <p:sp>
         <p:nvSpPr>
-          <p:cNvPr id="5" name="Shape 2"/>
+          <p:cNvPr id="4" name="Shape 1"/>
           <p:cNvSpPr/>
           <p:nvPr/>
         </p:nvSpPr>
@@ -4169,7 +4117,7 @@
       </p:sp>
       <p:sp>
         <p:nvSpPr>
-          <p:cNvPr id="6" name="Shape 3"/>
+          <p:cNvPr id="5" name="Shape 2"/>
           <p:cNvSpPr/>
           <p:nvPr/>
         </p:nvSpPr>
@@ -4189,7 +4137,7 @@
       </p:sp>
       <p:pic>
         <p:nvPicPr>
-          <p:cNvPr id="7" name="Image 0" descr="preencoded.png">    </p:cNvPr>
+          <p:cNvPr id="6" name="Image 0" descr="preencoded.png">    </p:cNvPr>
           <p:cNvPicPr>
             <a:picLocks noChangeAspect="1"/>
           </p:cNvPicPr>
@@ -4213,7 +4161,7 @@
       </p:pic>
       <p:sp>
         <p:nvSpPr>
-          <p:cNvPr id="8" name="Text 4"/>
+          <p:cNvPr id="7" name="Text 3"/>
           <p:cNvSpPr txBox="1"/>
           <p:nvPr/>
         </p:nvSpPr>
@@ -4255,7 +4203,7 @@
       </p:sp>
       <p:pic>
         <p:nvPicPr>
-          <p:cNvPr id="9" name="cst_single_Lg_best.png" descr="/home/user/fyp-mimo-antenna-metasurface/presentation/deck/.cache/cst_single_Lg_best_0_64_2077_959.png">    </p:cNvPr>
+          <p:cNvPr id="8" name="cst_single_Lg_best.png" descr="/home/user/fyp-mimo-antenna-metasurface/presentation/deck/.cache/cst_single_Lg_best_0_64_2077_959.png">    </p:cNvPr>
           <p:cNvPicPr>
             <a:picLocks noChangeAspect="1"/>
           </p:cNvPicPr>
@@ -4279,7 +4227,7 @@
       </p:pic>
       <p:sp>
         <p:nvSpPr>
-          <p:cNvPr id="10" name="Shape 5"/>
+          <p:cNvPr id="9" name="Shape 4"/>
           <p:cNvSpPr/>
           <p:nvPr/>
         </p:nvSpPr>
@@ -4302,7 +4250,7 @@
       </p:sp>
       <p:sp>
         <p:nvSpPr>
-          <p:cNvPr id="11" name="Text 6"/>
+          <p:cNvPr id="10" name="Text 5"/>
           <p:cNvSpPr txBox="1"/>
           <p:nvPr/>
         </p:nvSpPr>
@@ -4378,7 +4326,7 @@
       </p:sp>
       <p:sp>
         <p:nvSpPr>
-          <p:cNvPr id="12" name="Shape 7"/>
+          <p:cNvPr id="11" name="Shape 6"/>
           <p:cNvSpPr/>
           <p:nvPr/>
         </p:nvSpPr>
@@ -4401,23 +4349,65 @@
       </p:sp>
       <p:sp>
         <p:nvSpPr>
+          <p:cNvPr id="12" name="Text 7"/>
+          <p:cNvSpPr txBox="1"/>
+          <p:nvPr/>
+        </p:nvSpPr>
+        <p:spPr>
+          <a:xfrm>
+            <a:off x="4160520" y="4892040"/>
+            <a:ext cx="1554480" cy="329184"/>
+          </a:xfrm>
+          <a:prstGeom prst="rect">
+            <a:avLst/>
+          </a:prstGeom>
+          <a:noFill/>
+          <a:ln/>
+        </p:spPr>
+        <p:txBody>
+          <a:bodyPr wrap="square" lIns="0" tIns="0" rIns="0" bIns="0" rtlCol="0" anchor="ctr"/>
+          <a:lstStyle/>
+          <a:p>
+            <a:pPr algn="l" indent="0" marL="0">
+              <a:lnSpc>
+                <a:spcPct val="100000"/>
+              </a:lnSpc>
+              <a:buNone/>
+            </a:pPr>
+            <a:r>
+              <a:rPr lang="en-US" sz="1500" dirty="0">
+                <a:solidFill>
+                  <a:srgbClr val="5B6472"/>
+                </a:solidFill>
+                <a:latin typeface="Calibri" pitchFamily="34" charset="0"/>
+                <a:ea typeface="Calibri" pitchFamily="34" charset="-122"/>
+                <a:cs typeface="Calibri" pitchFamily="34" charset="-120"/>
+              </a:rPr>
+              <a:t>other values</a:t>
+            </a:r>
+            <a:endParaRPr lang="en-US" sz="1500" dirty="0"/>
+          </a:p>
+        </p:txBody>
+      </p:sp>
+      <p:sp>
+        <p:nvSpPr>
           <p:cNvPr id="13" name="Text 8"/>
           <p:cNvSpPr txBox="1"/>
           <p:nvPr/>
         </p:nvSpPr>
         <p:spPr>
           <a:xfrm>
-            <a:off x="4160520" y="4892040"/>
-            <a:ext cx="1554480" cy="329184"/>
-          </a:xfrm>
-          <a:prstGeom prst="rect">
-            <a:avLst/>
-          </a:prstGeom>
-          <a:noFill/>
-          <a:ln/>
-        </p:spPr>
-        <p:txBody>
-          <a:bodyPr wrap="square" lIns="0" tIns="0" rIns="0" bIns="0" rtlCol="0" anchor="ctr"/>
+            <a:off x="868680" y="5349240"/>
+            <a:ext cx="4747108" cy="329184"/>
+          </a:xfrm>
+          <a:prstGeom prst="rect">
+            <a:avLst/>
+          </a:prstGeom>
+          <a:noFill/>
+          <a:ln/>
+        </p:spPr>
+        <p:txBody>
+          <a:bodyPr wrap="square" lIns="0" tIns="0" rIns="0" bIns="0" rtlCol="0" anchor="t"/>
           <a:lstStyle/>
           <a:p>
             <a:pPr algn="l" indent="0" marL="0">
@@ -4429,13 +4419,47 @@
             <a:r>
               <a:rPr lang="en-US" sz="1500" dirty="0">
                 <a:solidFill>
-                  <a:srgbClr val="5B6472"/>
-                </a:solidFill>
-                <a:latin typeface="Calibri" pitchFamily="34" charset="0"/>
-                <a:ea typeface="Calibri" pitchFamily="34" charset="-122"/>
-                <a:cs typeface="Calibri" pitchFamily="34" charset="-120"/>
-              </a:rPr>
-              <a:t>other values</a:t>
+                  <a:srgbClr val="1F2328"/>
+                </a:solidFill>
+                <a:latin typeface="Calibri" pitchFamily="34" charset="0"/>
+                <a:ea typeface="Calibri" pitchFamily="34" charset="-122"/>
+                <a:cs typeface="Calibri" pitchFamily="34" charset="-120"/>
+              </a:rPr>
+              <a:t>10 positions: L</a:t>
+            </a:r>
+            <a:pPr algn="l" indent="0" marL="0">
+              <a:lnSpc>
+                <a:spcPct val="100000"/>
+              </a:lnSpc>
+              <a:buNone/>
+            </a:pPr>
+            <a:r>
+              <a:rPr lang="en-US" sz="1500" baseline="-40000" dirty="0">
+                <a:solidFill>
+                  <a:srgbClr val="1F2328"/>
+                </a:solidFill>
+                <a:latin typeface="Calibri" pitchFamily="34" charset="0"/>
+                <a:ea typeface="Calibri" pitchFamily="34" charset="-122"/>
+                <a:cs typeface="Calibri" pitchFamily="34" charset="-120"/>
+              </a:rPr>
+              <a:t>g</a:t>
+            </a:r>
+            <a:pPr algn="l" indent="0" marL="0">
+              <a:lnSpc>
+                <a:spcPct val="100000"/>
+              </a:lnSpc>
+              <a:buNone/>
+            </a:pPr>
+            <a:r>
+              <a:rPr lang="en-US" sz="1500" dirty="0">
+                <a:solidFill>
+                  <a:srgbClr val="1F2328"/>
+                </a:solidFill>
+                <a:latin typeface="Calibri" pitchFamily="34" charset="0"/>
+                <a:ea typeface="Calibri" pitchFamily="34" charset="-122"/>
+                <a:cs typeface="Calibri" pitchFamily="34" charset="-120"/>
+              </a:rPr>
+              <a:t> = −20 → −7 mm</a:t>
             </a:r>
             <a:endParaRPr lang="en-US" sz="1500" dirty="0"/>
           </a:p>
@@ -4449,82 +4473,6 @@
         </p:nvSpPr>
         <p:spPr>
           <a:xfrm>
-            <a:off x="868680" y="5349240"/>
-            <a:ext cx="4747108" cy="329184"/>
-          </a:xfrm>
-          <a:prstGeom prst="rect">
-            <a:avLst/>
-          </a:prstGeom>
-          <a:noFill/>
-          <a:ln/>
-        </p:spPr>
-        <p:txBody>
-          <a:bodyPr wrap="square" lIns="0" tIns="0" rIns="0" bIns="0" rtlCol="0" anchor="t"/>
-          <a:lstStyle/>
-          <a:p>
-            <a:pPr algn="l" indent="0" marL="0">
-              <a:lnSpc>
-                <a:spcPct val="100000"/>
-              </a:lnSpc>
-              <a:buNone/>
-            </a:pPr>
-            <a:r>
-              <a:rPr lang="en-US" sz="1500" dirty="0">
-                <a:solidFill>
-                  <a:srgbClr val="1F2328"/>
-                </a:solidFill>
-                <a:latin typeface="Calibri" pitchFamily="34" charset="0"/>
-                <a:ea typeface="Calibri" pitchFamily="34" charset="-122"/>
-                <a:cs typeface="Calibri" pitchFamily="34" charset="-120"/>
-              </a:rPr>
-              <a:t>10 positions: L</a:t>
-            </a:r>
-            <a:pPr algn="l" indent="0" marL="0">
-              <a:lnSpc>
-                <a:spcPct val="100000"/>
-              </a:lnSpc>
-              <a:buNone/>
-            </a:pPr>
-            <a:r>
-              <a:rPr lang="en-US" sz="1500" baseline="-40000" dirty="0">
-                <a:solidFill>
-                  <a:srgbClr val="1F2328"/>
-                </a:solidFill>
-                <a:latin typeface="Calibri" pitchFamily="34" charset="0"/>
-                <a:ea typeface="Calibri" pitchFamily="34" charset="-122"/>
-                <a:cs typeface="Calibri" pitchFamily="34" charset="-120"/>
-              </a:rPr>
-              <a:t>g</a:t>
-            </a:r>
-            <a:pPr algn="l" indent="0" marL="0">
-              <a:lnSpc>
-                <a:spcPct val="100000"/>
-              </a:lnSpc>
-              <a:buNone/>
-            </a:pPr>
-            <a:r>
-              <a:rPr lang="en-US" sz="1500" dirty="0">
-                <a:solidFill>
-                  <a:srgbClr val="1F2328"/>
-                </a:solidFill>
-                <a:latin typeface="Calibri" pitchFamily="34" charset="0"/>
-                <a:ea typeface="Calibri" pitchFamily="34" charset="-122"/>
-                <a:cs typeface="Calibri" pitchFamily="34" charset="-120"/>
-              </a:rPr>
-              <a:t> = −20 → −7 mm</a:t>
-            </a:r>
-            <a:endParaRPr lang="en-US" sz="1500" dirty="0"/>
-          </a:p>
-        </p:txBody>
-      </p:sp>
-      <p:sp>
-        <p:nvSpPr>
-          <p:cNvPr id="15" name="Text 10"/>
-          <p:cNvSpPr txBox="1"/>
-          <p:nvPr/>
-        </p:nvSpPr>
-        <p:spPr>
-          <a:xfrm>
             <a:off x="868680" y="5696712"/>
             <a:ext cx="4747108" cy="329184"/>
           </a:xfrm>
@@ -4561,7 +4509,7 @@
       </p:sp>
       <p:sp>
         <p:nvSpPr>
-          <p:cNvPr id="16" name="Shape 11"/>
+          <p:cNvPr id="15" name="Shape 10"/>
           <p:cNvSpPr/>
           <p:nvPr/>
         </p:nvSpPr>
@@ -4583,7 +4531,7 @@
       </p:sp>
       <p:sp>
         <p:nvSpPr>
-          <p:cNvPr id="17" name="Shape 12"/>
+          <p:cNvPr id="16" name="Shape 11"/>
           <p:cNvSpPr/>
           <p:nvPr/>
         </p:nvSpPr>
@@ -4603,7 +4551,7 @@
       </p:sp>
       <p:pic>
         <p:nvPicPr>
-          <p:cNvPr id="18" name="Image 2" descr="preencoded.png">    </p:cNvPr>
+          <p:cNvPr id="17" name="Image 2" descr="preencoded.png">    </p:cNvPr>
           <p:cNvPicPr>
             <a:picLocks noChangeAspect="1"/>
           </p:cNvPicPr>
@@ -4627,7 +4575,7 @@
       </p:pic>
       <p:sp>
         <p:nvSpPr>
-          <p:cNvPr id="19" name="Text 13"/>
+          <p:cNvPr id="18" name="Text 12"/>
           <p:cNvSpPr txBox="1"/>
           <p:nvPr/>
         </p:nvSpPr>
@@ -4669,7 +4617,7 @@
       </p:sp>
       <p:pic>
         <p:nvPicPr>
-          <p:cNvPr id="20" name="cst_single_R_best.png" descr="/home/user/fyp-mimo-antenna-metasurface/presentation/deck/.cache/cst_single_R_best_0_64_2088_959.png">    </p:cNvPr>
+          <p:cNvPr id="19" name="cst_single_R_best.png" descr="/home/user/fyp-mimo-antenna-metasurface/presentation/deck/.cache/cst_single_R_best_0_64_2088_959.png">    </p:cNvPr>
           <p:cNvPicPr>
             <a:picLocks noChangeAspect="1"/>
           </p:cNvPicPr>
@@ -4693,7 +4641,7 @@
       </p:pic>
       <p:sp>
         <p:nvSpPr>
-          <p:cNvPr id="21" name="Shape 14"/>
+          <p:cNvPr id="20" name="Shape 13"/>
           <p:cNvSpPr/>
           <p:nvPr/>
         </p:nvSpPr>
@@ -4716,7 +4664,7 @@
       </p:sp>
       <p:sp>
         <p:nvSpPr>
-          <p:cNvPr id="22" name="Text 15"/>
+          <p:cNvPr id="21" name="Text 14"/>
           <p:cNvSpPr txBox="1"/>
           <p:nvPr/>
         </p:nvSpPr>
@@ -4758,7 +4706,7 @@
       </p:sp>
       <p:sp>
         <p:nvSpPr>
-          <p:cNvPr id="23" name="Shape 16"/>
+          <p:cNvPr id="22" name="Shape 15"/>
           <p:cNvSpPr/>
           <p:nvPr/>
         </p:nvSpPr>
@@ -4781,23 +4729,65 @@
       </p:sp>
       <p:sp>
         <p:nvSpPr>
+          <p:cNvPr id="23" name="Text 16"/>
+          <p:cNvSpPr txBox="1"/>
+          <p:nvPr/>
+        </p:nvSpPr>
+        <p:spPr>
+          <a:xfrm>
+            <a:off x="9867748" y="4892040"/>
+            <a:ext cx="1554480" cy="329184"/>
+          </a:xfrm>
+          <a:prstGeom prst="rect">
+            <a:avLst/>
+          </a:prstGeom>
+          <a:noFill/>
+          <a:ln/>
+        </p:spPr>
+        <p:txBody>
+          <a:bodyPr wrap="square" lIns="0" tIns="0" rIns="0" bIns="0" rtlCol="0" anchor="ctr"/>
+          <a:lstStyle/>
+          <a:p>
+            <a:pPr algn="l" indent="0" marL="0">
+              <a:lnSpc>
+                <a:spcPct val="100000"/>
+              </a:lnSpc>
+              <a:buNone/>
+            </a:pPr>
+            <a:r>
+              <a:rPr lang="en-US" sz="1500" dirty="0">
+                <a:solidFill>
+                  <a:srgbClr val="5B6472"/>
+                </a:solidFill>
+                <a:latin typeface="Calibri" pitchFamily="34" charset="0"/>
+                <a:ea typeface="Calibri" pitchFamily="34" charset="-122"/>
+                <a:cs typeface="Calibri" pitchFamily="34" charset="-120"/>
+              </a:rPr>
+              <a:t>other values</a:t>
+            </a:r>
+            <a:endParaRPr lang="en-US" sz="1500" dirty="0"/>
+          </a:p>
+        </p:txBody>
+      </p:sp>
+      <p:sp>
+        <p:nvSpPr>
           <p:cNvPr id="24" name="Text 17"/>
           <p:cNvSpPr txBox="1"/>
           <p:nvPr/>
         </p:nvSpPr>
         <p:spPr>
           <a:xfrm>
-            <a:off x="9867748" y="4892040"/>
-            <a:ext cx="1554480" cy="329184"/>
-          </a:xfrm>
-          <a:prstGeom prst="rect">
-            <a:avLst/>
-          </a:prstGeom>
-          <a:noFill/>
-          <a:ln/>
-        </p:spPr>
-        <p:txBody>
-          <a:bodyPr wrap="square" lIns="0" tIns="0" rIns="0" bIns="0" rtlCol="0" anchor="ctr"/>
+            <a:off x="6575908" y="5349240"/>
+            <a:ext cx="4747108" cy="329184"/>
+          </a:xfrm>
+          <a:prstGeom prst="rect">
+            <a:avLst/>
+          </a:prstGeom>
+          <a:noFill/>
+          <a:ln/>
+        </p:spPr>
+        <p:txBody>
+          <a:bodyPr wrap="square" lIns="0" tIns="0" rIns="0" bIns="0" rtlCol="0" anchor="t"/>
           <a:lstStyle/>
           <a:p>
             <a:pPr algn="l" indent="0" marL="0">
@@ -4809,13 +4799,13 @@
             <a:r>
               <a:rPr lang="en-US" sz="1500" dirty="0">
                 <a:solidFill>
-                  <a:srgbClr val="5B6472"/>
-                </a:solidFill>
-                <a:latin typeface="Calibri" pitchFamily="34" charset="0"/>
-                <a:ea typeface="Calibri" pitchFamily="34" charset="-122"/>
-                <a:cs typeface="Calibri" pitchFamily="34" charset="-120"/>
-              </a:rPr>
-              <a:t>other values</a:t>
+                  <a:srgbClr val="1F2328"/>
+                </a:solidFill>
+                <a:latin typeface="Calibri" pitchFamily="34" charset="0"/>
+                <a:ea typeface="Calibri" pitchFamily="34" charset="-122"/>
+                <a:cs typeface="Calibri" pitchFamily="34" charset="-120"/>
+              </a:rPr>
+              <a:t>13 sizes: R = 4 → 15 mm</a:t>
             </a:r>
             <a:endParaRPr lang="en-US" sz="1500" dirty="0"/>
           </a:p>
@@ -4829,48 +4819,6 @@
         </p:nvSpPr>
         <p:spPr>
           <a:xfrm>
-            <a:off x="6575908" y="5349240"/>
-            <a:ext cx="4747108" cy="329184"/>
-          </a:xfrm>
-          <a:prstGeom prst="rect">
-            <a:avLst/>
-          </a:prstGeom>
-          <a:noFill/>
-          <a:ln/>
-        </p:spPr>
-        <p:txBody>
-          <a:bodyPr wrap="square" lIns="0" tIns="0" rIns="0" bIns="0" rtlCol="0" anchor="t"/>
-          <a:lstStyle/>
-          <a:p>
-            <a:pPr algn="l" indent="0" marL="0">
-              <a:lnSpc>
-                <a:spcPct val="100000"/>
-              </a:lnSpc>
-              <a:buNone/>
-            </a:pPr>
-            <a:r>
-              <a:rPr lang="en-US" sz="1500" dirty="0">
-                <a:solidFill>
-                  <a:srgbClr val="1F2328"/>
-                </a:solidFill>
-                <a:latin typeface="Calibri" pitchFamily="34" charset="0"/>
-                <a:ea typeface="Calibri" pitchFamily="34" charset="-122"/>
-                <a:cs typeface="Calibri" pitchFamily="34" charset="-120"/>
-              </a:rPr>
-              <a:t>13 sizes: R = 4 → 15 mm</a:t>
-            </a:r>
-            <a:endParaRPr lang="en-US" sz="1500" dirty="0"/>
-          </a:p>
-        </p:txBody>
-      </p:sp>
-      <p:sp>
-        <p:nvSpPr>
-          <p:cNvPr id="26" name="Text 19"/>
-          <p:cNvSpPr txBox="1"/>
-          <p:nvPr/>
-        </p:nvSpPr>
-        <p:spPr>
-          <a:xfrm>
             <a:off x="6575908" y="5696712"/>
             <a:ext cx="4747108" cy="329184"/>
           </a:xfrm>
@@ -4902,6 +4850,36 @@
               <a:t>Bigger patch → resonances join into one band</a:t>
             </a:r>
             <a:endParaRPr lang="en-US" sz="1500" dirty="0"/>
+          </a:p>
+        </p:txBody>
+      </p:sp>
+      <p:sp>
+        <p:nvSpPr>
+          <p:cNvPr id="26" name="Text 0"/>
+          <p:cNvSpPr/>
+          <p:nvPr>
+            <p:ph idx="100" type="body" hasCustomPrompt="1"/>
+          </p:nvPr>
+        </p:nvSpPr>
+        <p:spPr>
+          <a:xfrm>
+            <a:off x="548640" y="347472"/>
+            <a:ext cx="8229600" cy="292608"/>
+          </a:xfrm>
+          <a:prstGeom prst="rect">
+            <a:avLst/>
+          </a:prstGeom>
+          <a:noFill/>
+          <a:ln/>
+        </p:spPr>
+        <p:txBody>
+          <a:bodyPr wrap="square" lIns="0" tIns="0" rIns="0" bIns="0" rtlCol="0" anchor="ctr"/>
+          <a:lstStyle/>
+          <a:p>
+            <a:pPr indent="0" marL="0">
+              <a:buNone/>
+            </a:pPr>
+            <a:endParaRPr lang="en-US" sz="1300" dirty="0"/>
           </a:p>
         </p:txBody>
       </p:sp>
@@ -4983,47 +4961,6 @@
           <p:cNvPr id="2" name="Text 0"/>
           <p:cNvSpPr/>
           <p:nvPr>
-            <p:ph idx="100" type="body" hasCustomPrompt="1"/>
-          </p:nvPr>
-        </p:nvSpPr>
-        <p:spPr>
-          <a:xfrm>
-            <a:off x="548640" y="347472"/>
-            <a:ext cx="8229600" cy="292608"/>
-          </a:xfrm>
-          <a:prstGeom prst="rect">
-            <a:avLst/>
-          </a:prstGeom>
-          <a:noFill/>
-          <a:ln/>
-        </p:spPr>
-        <p:txBody>
-          <a:bodyPr wrap="square" lIns="0" tIns="0" rIns="0" bIns="0" rtlCol="0" anchor="ctr"/>
-          <a:lstStyle/>
-          <a:p>
-            <a:pPr indent="0" marL="0">
-              <a:buNone/>
-            </a:pPr>
-            <a:r>
-              <a:rPr lang="en-US" sz="1300" b="1" spc="150" kern="0" dirty="0">
-                <a:solidFill>
-                  <a:srgbClr val="B8651B"/>
-                </a:solidFill>
-                <a:latin typeface="Calibri" pitchFamily="34" charset="0"/>
-                <a:ea typeface="Calibri" pitchFamily="34" charset="-122"/>
-                <a:cs typeface="Calibri" pitchFamily="34" charset="-120"/>
-              </a:rPr>
-              <a:t>WORK DONE · 3</a:t>
-            </a:r>
-            <a:endParaRPr lang="en-US" sz="1300" dirty="0"/>
-          </a:p>
-        </p:txBody>
-      </p:sp>
-      <p:sp>
-        <p:nvSpPr>
-          <p:cNvPr id="3" name="Text 0"/>
-          <p:cNvSpPr/>
-          <p:nvPr>
             <p:ph idx="101" type="title" hasCustomPrompt="1"/>
           </p:nvPr>
         </p:nvSpPr>
@@ -5062,7 +4999,7 @@
       </p:sp>
       <p:sp>
         <p:nvSpPr>
-          <p:cNvPr id="5" name="Shape 2"/>
+          <p:cNvPr id="4" name="Shape 1"/>
           <p:cNvSpPr/>
           <p:nvPr/>
         </p:nvSpPr>
@@ -5084,7 +5021,7 @@
       </p:sp>
       <p:pic>
         <p:nvPicPr>
-          <p:cNvPr id="6" name="cst_final_antenna.png" descr="/home/user/fyp-mimo-antenna-metasurface/figures/cst_final_antenna.png">    </p:cNvPr>
+          <p:cNvPr id="5" name="cst_final_antenna.png" descr="/home/user/fyp-mimo-antenna-metasurface/figures/cst_final_antenna.png">    </p:cNvPr>
           <p:cNvPicPr>
             <a:picLocks noChangeAspect="1"/>
           </p:cNvPicPr>
@@ -5108,14 +5045,56 @@
       </p:pic>
       <p:sp>
         <p:nvSpPr>
+          <p:cNvPr id="6" name="Text 2"/>
+          <p:cNvSpPr txBox="1"/>
+          <p:nvPr/>
+        </p:nvSpPr>
+        <p:spPr>
+          <a:xfrm>
+            <a:off x="822960" y="4754880"/>
+            <a:ext cx="1143000" cy="365760"/>
+          </a:xfrm>
+          <a:prstGeom prst="rect">
+            <a:avLst/>
+          </a:prstGeom>
+          <a:noFill/>
+          <a:ln/>
+        </p:spPr>
+        <p:txBody>
+          <a:bodyPr wrap="square" lIns="0" tIns="0" rIns="0" bIns="0" rtlCol="0" anchor="ctr"/>
+          <a:lstStyle/>
+          <a:p>
+            <a:pPr algn="l" indent="0" marL="0">
+              <a:lnSpc>
+                <a:spcPct val="100000"/>
+              </a:lnSpc>
+              <a:buNone/>
+            </a:pPr>
+            <a:r>
+              <a:rPr lang="en-US" sz="1400" b="1" dirty="0">
+                <a:solidFill>
+                  <a:srgbClr val="17324D"/>
+                </a:solidFill>
+                <a:latin typeface="Calibri" pitchFamily="34" charset="0"/>
+                <a:ea typeface="Calibri" pitchFamily="34" charset="-122"/>
+                <a:cs typeface="Calibri" pitchFamily="34" charset="-120"/>
+              </a:rPr>
+              <a:t>Board</a:t>
+            </a:r>
+            <a:endParaRPr lang="en-US" sz="1400" dirty="0"/>
+          </a:p>
+        </p:txBody>
+      </p:sp>
+      <p:sp>
+        <p:nvSpPr>
           <p:cNvPr id="7" name="Text 3"/>
           <p:cNvSpPr txBox="1"/>
           <p:nvPr/>
         </p:nvSpPr>
         <p:spPr>
           <a:xfrm>
-            <a:off x="822960" y="4754880"/>
-            <a:ext cx="1143000" cy="365760"/>
+            <a:off x="1920240" y="4754880"/>
+            <a:ext cx="2011680" cy="365760"/>
           </a:xfrm>
           <a:prstGeom prst="rect">
             <a:avLst/>
@@ -5134,15 +5113,15 @@
               <a:buNone/>
             </a:pPr>
             <a:r>
-              <a:rPr lang="en-US" sz="1400" b="1" dirty="0">
-                <a:solidFill>
-                  <a:srgbClr val="17324D"/>
-                </a:solidFill>
-                <a:latin typeface="Calibri" pitchFamily="34" charset="0"/>
-                <a:ea typeface="Calibri" pitchFamily="34" charset="-122"/>
-                <a:cs typeface="Calibri" pitchFamily="34" charset="-120"/>
-              </a:rPr>
-              <a:t>Board</a:t>
+              <a:rPr lang="en-US" sz="1400" dirty="0">
+                <a:solidFill>
+                  <a:srgbClr val="1F2328"/>
+                </a:solidFill>
+                <a:latin typeface="Calibri" pitchFamily="34" charset="0"/>
+                <a:ea typeface="Calibri" pitchFamily="34" charset="-122"/>
+                <a:cs typeface="Calibri" pitchFamily="34" charset="-120"/>
+              </a:rPr>
+              <a:t>FR-4, 50 × 50 × 1.6 mm</a:t>
             </a:r>
             <a:endParaRPr lang="en-US" sz="1400" dirty="0"/>
           </a:p>
@@ -5156,8 +5135,8 @@
         </p:nvSpPr>
         <p:spPr>
           <a:xfrm>
-            <a:off x="1920240" y="4754880"/>
-            <a:ext cx="2011680" cy="365760"/>
+            <a:off x="822960" y="5193792"/>
+            <a:ext cx="1143000" cy="365760"/>
           </a:xfrm>
           <a:prstGeom prst="rect">
             <a:avLst/>
@@ -5176,15 +5155,15 @@
               <a:buNone/>
             </a:pPr>
             <a:r>
-              <a:rPr lang="en-US" sz="1400" dirty="0">
-                <a:solidFill>
-                  <a:srgbClr val="1F2328"/>
-                </a:solidFill>
-                <a:latin typeface="Calibri" pitchFamily="34" charset="0"/>
-                <a:ea typeface="Calibri" pitchFamily="34" charset="-122"/>
-                <a:cs typeface="Calibri" pitchFamily="34" charset="-120"/>
-              </a:rPr>
-              <a:t>FR-4, 50 × 50 × 1.6 mm</a:t>
+              <a:rPr lang="en-US" sz="1400" b="1" dirty="0">
+                <a:solidFill>
+                  <a:srgbClr val="17324D"/>
+                </a:solidFill>
+                <a:latin typeface="Calibri" pitchFamily="34" charset="0"/>
+                <a:ea typeface="Calibri" pitchFamily="34" charset="-122"/>
+                <a:cs typeface="Calibri" pitchFamily="34" charset="-120"/>
+              </a:rPr>
+              <a:t>Patch</a:t>
             </a:r>
             <a:endParaRPr lang="en-US" sz="1400" dirty="0"/>
           </a:p>
@@ -5198,8 +5177,8 @@
         </p:nvSpPr>
         <p:spPr>
           <a:xfrm>
-            <a:off x="822960" y="5193792"/>
-            <a:ext cx="1143000" cy="365760"/>
+            <a:off x="1920240" y="5193792"/>
+            <a:ext cx="2011680" cy="365760"/>
           </a:xfrm>
           <a:prstGeom prst="rect">
             <a:avLst/>
@@ -5218,15 +5197,15 @@
               <a:buNone/>
             </a:pPr>
             <a:r>
-              <a:rPr lang="en-US" sz="1400" b="1" dirty="0">
-                <a:solidFill>
-                  <a:srgbClr val="17324D"/>
-                </a:solidFill>
-                <a:latin typeface="Calibri" pitchFamily="34" charset="0"/>
-                <a:ea typeface="Calibri" pitchFamily="34" charset="-122"/>
-                <a:cs typeface="Calibri" pitchFamily="34" charset="-120"/>
-              </a:rPr>
-              <a:t>Patch</a:t>
+              <a:rPr lang="en-US" sz="1400" dirty="0">
+                <a:solidFill>
+                  <a:srgbClr val="1F2328"/>
+                </a:solidFill>
+                <a:latin typeface="Calibri" pitchFamily="34" charset="0"/>
+                <a:ea typeface="Calibri" pitchFamily="34" charset="-122"/>
+                <a:cs typeface="Calibri" pitchFamily="34" charset="-120"/>
+              </a:rPr>
+              <a:t>decagon, R = 15 mm</a:t>
             </a:r>
             <a:endParaRPr lang="en-US" sz="1400" dirty="0"/>
           </a:p>
@@ -5240,8 +5219,8 @@
         </p:nvSpPr>
         <p:spPr>
           <a:xfrm>
-            <a:off x="1920240" y="5193792"/>
-            <a:ext cx="2011680" cy="365760"/>
+            <a:off x="822960" y="5632704"/>
+            <a:ext cx="1143000" cy="365760"/>
           </a:xfrm>
           <a:prstGeom prst="rect">
             <a:avLst/>
@@ -5260,15 +5239,15 @@
               <a:buNone/>
             </a:pPr>
             <a:r>
-              <a:rPr lang="en-US" sz="1400" dirty="0">
-                <a:solidFill>
-                  <a:srgbClr val="1F2328"/>
-                </a:solidFill>
-                <a:latin typeface="Calibri" pitchFamily="34" charset="0"/>
-                <a:ea typeface="Calibri" pitchFamily="34" charset="-122"/>
-                <a:cs typeface="Calibri" pitchFamily="34" charset="-120"/>
-              </a:rPr>
-              <a:t>decagon, R = 15 mm</a:t>
+              <a:rPr lang="en-US" sz="1400" b="1" dirty="0">
+                <a:solidFill>
+                  <a:srgbClr val="17324D"/>
+                </a:solidFill>
+                <a:latin typeface="Calibri" pitchFamily="34" charset="0"/>
+                <a:ea typeface="Calibri" pitchFamily="34" charset="-122"/>
+                <a:cs typeface="Calibri" pitchFamily="34" charset="-120"/>
+              </a:rPr>
+              <a:t>Ground edge</a:t>
             </a:r>
             <a:endParaRPr lang="en-US" sz="1400" dirty="0"/>
           </a:p>
@@ -5282,48 +5261,6 @@
         </p:nvSpPr>
         <p:spPr>
           <a:xfrm>
-            <a:off x="822960" y="5632704"/>
-            <a:ext cx="1143000" cy="365760"/>
-          </a:xfrm>
-          <a:prstGeom prst="rect">
-            <a:avLst/>
-          </a:prstGeom>
-          <a:noFill/>
-          <a:ln/>
-        </p:spPr>
-        <p:txBody>
-          <a:bodyPr wrap="square" lIns="0" tIns="0" rIns="0" bIns="0" rtlCol="0" anchor="ctr"/>
-          <a:lstStyle/>
-          <a:p>
-            <a:pPr algn="l" indent="0" marL="0">
-              <a:lnSpc>
-                <a:spcPct val="100000"/>
-              </a:lnSpc>
-              <a:buNone/>
-            </a:pPr>
-            <a:r>
-              <a:rPr lang="en-US" sz="1400" b="1" dirty="0">
-                <a:solidFill>
-                  <a:srgbClr val="17324D"/>
-                </a:solidFill>
-                <a:latin typeface="Calibri" pitchFamily="34" charset="0"/>
-                <a:ea typeface="Calibri" pitchFamily="34" charset="-122"/>
-                <a:cs typeface="Calibri" pitchFamily="34" charset="-120"/>
-              </a:rPr>
-              <a:t>Ground edge</a:t>
-            </a:r>
-            <a:endParaRPr lang="en-US" sz="1400" dirty="0"/>
-          </a:p>
-        </p:txBody>
-      </p:sp>
-      <p:sp>
-        <p:nvSpPr>
-          <p:cNvPr id="12" name="Text 8"/>
-          <p:cNvSpPr txBox="1"/>
-          <p:nvPr/>
-        </p:nvSpPr>
-        <p:spPr>
-          <a:xfrm>
             <a:off x="1920240" y="5632704"/>
             <a:ext cx="2011680" cy="365760"/>
           </a:xfrm>
@@ -5394,7 +5331,7 @@
       </p:sp>
       <p:pic>
         <p:nvPicPr>
-          <p:cNvPr id="13" name="cst_single_final_s11_bandwidth.png" descr="/home/user/fyp-mimo-antenna-metasurface/presentation/deck/.cache/cst_single_final_s11_bandwidth_0_64_2178_959.png">    </p:cNvPr>
+          <p:cNvPr id="12" name="cst_single_final_s11_bandwidth.png" descr="/home/user/fyp-mimo-antenna-metasurface/presentation/deck/.cache/cst_single_final_s11_bandwidth_0_64_2178_959.png">    </p:cNvPr>
           <p:cNvPicPr>
             <a:picLocks noChangeAspect="1"/>
           </p:cNvPicPr>
@@ -5418,7 +5355,7 @@
       </p:pic>
       <p:sp>
         <p:nvSpPr>
-          <p:cNvPr id="14" name="Shape 9"/>
+          <p:cNvPr id="13" name="Shape 8"/>
           <p:cNvSpPr/>
           <p:nvPr/>
         </p:nvSpPr>
@@ -5440,7 +5377,7 @@
       </p:sp>
       <p:sp>
         <p:nvSpPr>
-          <p:cNvPr id="15" name="Text 10"/>
+          <p:cNvPr id="14" name="Text 9"/>
           <p:cNvSpPr txBox="1"/>
           <p:nvPr/>
         </p:nvSpPr>
@@ -5482,7 +5419,7 @@
       </p:sp>
       <p:sp>
         <p:nvSpPr>
-          <p:cNvPr id="16" name="Text 11"/>
+          <p:cNvPr id="15" name="Text 10"/>
           <p:cNvSpPr txBox="1"/>
           <p:nvPr/>
         </p:nvSpPr>
@@ -5558,7 +5495,7 @@
       </p:sp>
       <p:sp>
         <p:nvSpPr>
-          <p:cNvPr id="17" name="Shape 12"/>
+          <p:cNvPr id="16" name="Shape 11"/>
           <p:cNvSpPr/>
           <p:nvPr/>
         </p:nvSpPr>
@@ -5578,7 +5515,7 @@
       </p:sp>
       <p:pic>
         <p:nvPicPr>
-          <p:cNvPr id="18" name="Image 2" descr="preencoded.png">    </p:cNvPr>
+          <p:cNvPr id="17" name="Image 2" descr="preencoded.png">    </p:cNvPr>
           <p:cNvPicPr>
             <a:picLocks noChangeAspect="1"/>
           </p:cNvPicPr>
@@ -5602,7 +5539,7 @@
       </p:pic>
       <p:sp>
         <p:nvSpPr>
-          <p:cNvPr id="19" name="Text 13"/>
+          <p:cNvPr id="18" name="Text 12"/>
           <p:cNvSpPr txBox="1"/>
           <p:nvPr/>
         </p:nvSpPr>
@@ -5644,7 +5581,7 @@
       </p:sp>
       <p:sp>
         <p:nvSpPr>
-          <p:cNvPr id="20" name="Shape 14"/>
+          <p:cNvPr id="19" name="Shape 13"/>
           <p:cNvSpPr/>
           <p:nvPr/>
         </p:nvSpPr>
@@ -5664,7 +5601,7 @@
       </p:sp>
       <p:pic>
         <p:nvPicPr>
-          <p:cNvPr id="21" name="Image 3" descr="preencoded.png">    </p:cNvPr>
+          <p:cNvPr id="20" name="Image 3" descr="preencoded.png">    </p:cNvPr>
           <p:cNvPicPr>
             <a:picLocks noChangeAspect="1"/>
           </p:cNvPicPr>
@@ -5688,7 +5625,7 @@
       </p:pic>
       <p:sp>
         <p:nvSpPr>
-          <p:cNvPr id="22" name="Text 15"/>
+          <p:cNvPr id="21" name="Text 14"/>
           <p:cNvSpPr txBox="1"/>
           <p:nvPr/>
         </p:nvSpPr>
@@ -5730,7 +5667,7 @@
       </p:sp>
       <p:sp>
         <p:nvSpPr>
-          <p:cNvPr id="23" name="Shape 16"/>
+          <p:cNvPr id="22" name="Shape 15"/>
           <p:cNvSpPr/>
           <p:nvPr/>
         </p:nvSpPr>
@@ -5750,7 +5687,7 @@
       </p:sp>
       <p:pic>
         <p:nvPicPr>
-          <p:cNvPr id="24" name="Image 4" descr="preencoded.png">    </p:cNvPr>
+          <p:cNvPr id="23" name="Image 4" descr="preencoded.png">    </p:cNvPr>
           <p:cNvPicPr>
             <a:picLocks noChangeAspect="1"/>
           </p:cNvPicPr>
@@ -5774,7 +5711,7 @@
       </p:pic>
       <p:sp>
         <p:nvSpPr>
-          <p:cNvPr id="25" name="Text 17"/>
+          <p:cNvPr id="24" name="Text 16"/>
           <p:cNvSpPr txBox="1"/>
           <p:nvPr/>
         </p:nvSpPr>
@@ -5811,6 +5748,36 @@
               <a:t>covers the 2–15 GHz target</a:t>
             </a:r>
             <a:endParaRPr lang="en-US" sz="1500" dirty="0"/>
+          </a:p>
+        </p:txBody>
+      </p:sp>
+      <p:sp>
+        <p:nvSpPr>
+          <p:cNvPr id="25" name="Text 0"/>
+          <p:cNvSpPr/>
+          <p:nvPr>
+            <p:ph idx="100" type="body" hasCustomPrompt="1"/>
+          </p:nvPr>
+        </p:nvSpPr>
+        <p:spPr>
+          <a:xfrm>
+            <a:off x="548640" y="347472"/>
+            <a:ext cx="8229600" cy="292608"/>
+          </a:xfrm>
+          <a:prstGeom prst="rect">
+            <a:avLst/>
+          </a:prstGeom>
+          <a:noFill/>
+          <a:ln/>
+        </p:spPr>
+        <p:txBody>
+          <a:bodyPr wrap="square" lIns="0" tIns="0" rIns="0" bIns="0" rtlCol="0" anchor="ctr"/>
+          <a:lstStyle/>
+          <a:p>
+            <a:pPr indent="0" marL="0">
+              <a:buNone/>
+            </a:pPr>
+            <a:endParaRPr lang="en-US" sz="1300" dirty="0"/>
           </a:p>
         </p:txBody>
       </p:sp>
@@ -5892,47 +5859,6 @@
           <p:cNvPr id="2" name="Text 0"/>
           <p:cNvSpPr/>
           <p:nvPr>
-            <p:ph idx="100" type="body" hasCustomPrompt="1"/>
-          </p:nvPr>
-        </p:nvSpPr>
-        <p:spPr>
-          <a:xfrm>
-            <a:off x="548640" y="347472"/>
-            <a:ext cx="8229600" cy="292608"/>
-          </a:xfrm>
-          <a:prstGeom prst="rect">
-            <a:avLst/>
-          </a:prstGeom>
-          <a:noFill/>
-          <a:ln/>
-        </p:spPr>
-        <p:txBody>
-          <a:bodyPr wrap="square" lIns="0" tIns="0" rIns="0" bIns="0" rtlCol="0" anchor="ctr"/>
-          <a:lstStyle/>
-          <a:p>
-            <a:pPr indent="0" marL="0">
-              <a:buNone/>
-            </a:pPr>
-            <a:r>
-              <a:rPr lang="en-US" sz="1300" b="1" spc="150" kern="0" dirty="0">
-                <a:solidFill>
-                  <a:srgbClr val="B8651B"/>
-                </a:solidFill>
-                <a:latin typeface="Calibri" pitchFamily="34" charset="0"/>
-                <a:ea typeface="Calibri" pitchFamily="34" charset="-122"/>
-                <a:cs typeface="Calibri" pitchFamily="34" charset="-120"/>
-              </a:rPr>
-              <a:t>WORK DONE · 4</a:t>
-            </a:r>
-            <a:endParaRPr lang="en-US" sz="1300" dirty="0"/>
-          </a:p>
-        </p:txBody>
-      </p:sp>
-      <p:sp>
-        <p:nvSpPr>
-          <p:cNvPr id="3" name="Text 0"/>
-          <p:cNvSpPr/>
-          <p:nvPr>
             <p:ph idx="101" type="title" hasCustomPrompt="1"/>
           </p:nvPr>
         </p:nvSpPr>
@@ -5971,7 +5897,7 @@
       </p:sp>
       <p:sp>
         <p:nvSpPr>
-          <p:cNvPr id="5" name="Text 2"/>
+          <p:cNvPr id="4" name="Text 1"/>
           <p:cNvSpPr txBox="1"/>
           <p:nvPr/>
         </p:nvSpPr>
@@ -6013,7 +5939,7 @@
       </p:sp>
       <p:pic>
         <p:nvPicPr>
-          <p:cNvPr id="6" name="cst_single_final_s11.png" descr="/home/user/fyp-mimo-antenna-metasurface/presentation/deck/.cache/cst_single_final_s11_0_64_2178_959.png">    </p:cNvPr>
+          <p:cNvPr id="5" name="cst_single_final_s11.png" descr="/home/user/fyp-mimo-antenna-metasurface/presentation/deck/.cache/cst_single_final_s11_0_64_2178_959.png">    </p:cNvPr>
           <p:cNvPicPr>
             <a:picLocks noChangeAspect="1"/>
           </p:cNvPicPr>
@@ -6037,7 +5963,7 @@
       </p:pic>
       <p:sp>
         <p:nvSpPr>
-          <p:cNvPr id="7" name="Shape 3"/>
+          <p:cNvPr id="6" name="Shape 2"/>
           <p:cNvSpPr/>
           <p:nvPr/>
         </p:nvSpPr>
@@ -6059,7 +5985,7 @@
       </p:sp>
       <p:sp>
         <p:nvSpPr>
-          <p:cNvPr id="8" name="Text 4"/>
+          <p:cNvPr id="7" name="Text 3"/>
           <p:cNvSpPr txBox="1"/>
           <p:nvPr/>
         </p:nvSpPr>
@@ -6093,7 +6019,7 @@
                 <a:ea typeface="Calibri" pitchFamily="34" charset="-122"/>
                 <a:cs typeface="Calibri" pitchFamily="34" charset="-120"/>
               </a:rPr>
-              <a:t>Antenna + metasurface (3.9 mm gap)</a:t>
+              <a:t>Antenna + metasurface (2 mm gap)</a:t>
             </a:r>
             <a:endParaRPr lang="en-US" sz="1500" dirty="0"/>
           </a:p>
@@ -6101,7 +6027,7 @@
       </p:sp>
       <p:pic>
         <p:nvPicPr>
-          <p:cNvPr id="9" name="cst_single_ms_s11.png" descr="/home/user/fyp-mimo-antenna-metasurface/presentation/deck/.cache/cst_single_ms_s11_0_64_2178_959.png">    </p:cNvPr>
+          <p:cNvPr id="8" name="cst_single_ms_s11.png" descr="/home/user/fyp-mimo-antenna-metasurface/presentation/deck/.cache/cst_single_ms_s11_0_64_2178_959.png">    </p:cNvPr>
           <p:cNvPicPr>
             <a:picLocks noChangeAspect="1"/>
           </p:cNvPicPr>
@@ -6125,7 +6051,7 @@
       </p:pic>
       <p:sp>
         <p:nvSpPr>
-          <p:cNvPr id="10" name="Shape 5"/>
+          <p:cNvPr id="9" name="Shape 4"/>
           <p:cNvSpPr/>
           <p:nvPr/>
         </p:nvSpPr>
@@ -6147,7 +6073,7 @@
       </p:sp>
       <p:sp>
         <p:nvSpPr>
-          <p:cNvPr id="11" name="Shape 6"/>
+          <p:cNvPr id="10" name="Shape 5"/>
           <p:cNvSpPr/>
           <p:nvPr/>
         </p:nvSpPr>
@@ -6169,7 +6095,7 @@
       </p:sp>
       <p:sp>
         <p:nvSpPr>
-          <p:cNvPr id="12" name="Shape 7"/>
+          <p:cNvPr id="11" name="Shape 6"/>
           <p:cNvSpPr/>
           <p:nvPr/>
         </p:nvSpPr>
@@ -6191,7 +6117,7 @@
       </p:sp>
       <p:sp>
         <p:nvSpPr>
-          <p:cNvPr id="13" name="Shape 8"/>
+          <p:cNvPr id="12" name="Shape 7"/>
           <p:cNvSpPr/>
           <p:nvPr/>
         </p:nvSpPr>
@@ -6213,7 +6139,7 @@
       </p:sp>
       <p:sp>
         <p:nvSpPr>
-          <p:cNvPr id="14" name="Shape 9"/>
+          <p:cNvPr id="13" name="Shape 8"/>
           <p:cNvSpPr/>
           <p:nvPr/>
         </p:nvSpPr>
@@ -6235,7 +6161,7 @@
       </p:sp>
       <p:sp>
         <p:nvSpPr>
-          <p:cNvPr id="15" name="Shape 10"/>
+          <p:cNvPr id="14" name="Shape 9"/>
           <p:cNvSpPr/>
           <p:nvPr/>
         </p:nvSpPr>
@@ -6255,7 +6181,7 @@
       </p:sp>
       <p:pic>
         <p:nvPicPr>
-          <p:cNvPr id="16" name="Image 2" descr="preencoded.png">    </p:cNvPr>
+          <p:cNvPr id="15" name="Image 2" descr="preencoded.png">    </p:cNvPr>
           <p:cNvPicPr>
             <a:picLocks noChangeAspect="1"/>
           </p:cNvPicPr>
@@ -6279,54 +6205,54 @@
       </p:pic>
       <p:sp>
         <p:nvSpPr>
+          <p:cNvPr id="16" name="Text 10"/>
+          <p:cNvSpPr txBox="1"/>
+          <p:nvPr/>
+        </p:nvSpPr>
+        <p:spPr>
+          <a:xfrm>
+            <a:off x="6926963" y="1645920"/>
+            <a:ext cx="4578932" cy="411480"/>
+          </a:xfrm>
+          <a:prstGeom prst="rect">
+            <a:avLst/>
+          </a:prstGeom>
+          <a:noFill/>
+          <a:ln/>
+        </p:spPr>
+        <p:txBody>
+          <a:bodyPr wrap="square" lIns="0" tIns="0" rIns="0" bIns="0" rtlCol="0" anchor="t"/>
+          <a:lstStyle/>
+          <a:p>
+            <a:pPr algn="l" indent="0" marL="0">
+              <a:lnSpc>
+                <a:spcPct val="100000"/>
+              </a:lnSpc>
+              <a:buNone/>
+            </a:pPr>
+            <a:r>
+              <a:rPr lang="en-US" sz="1900" b="1" dirty="0">
+                <a:solidFill>
+                  <a:srgbClr val="2E7D5B"/>
+                </a:solidFill>
+                <a:latin typeface="Calibri" pitchFamily="34" charset="0"/>
+                <a:ea typeface="Calibri" pitchFamily="34" charset="-122"/>
+                <a:cs typeface="Calibri" pitchFamily="34" charset="-120"/>
+              </a:rPr>
+              <a:t>Wider band</a:t>
+            </a:r>
+            <a:endParaRPr lang="en-US" sz="1900" dirty="0"/>
+          </a:p>
+        </p:txBody>
+      </p:sp>
+      <p:sp>
+        <p:nvSpPr>
           <p:cNvPr id="17" name="Text 11"/>
           <p:cNvSpPr txBox="1"/>
           <p:nvPr/>
         </p:nvSpPr>
         <p:spPr>
           <a:xfrm>
-            <a:off x="6926963" y="1645920"/>
-            <a:ext cx="4578932" cy="411480"/>
-          </a:xfrm>
-          <a:prstGeom prst="rect">
-            <a:avLst/>
-          </a:prstGeom>
-          <a:noFill/>
-          <a:ln/>
-        </p:spPr>
-        <p:txBody>
-          <a:bodyPr wrap="square" lIns="0" tIns="0" rIns="0" bIns="0" rtlCol="0" anchor="t"/>
-          <a:lstStyle/>
-          <a:p>
-            <a:pPr algn="l" indent="0" marL="0">
-              <a:lnSpc>
-                <a:spcPct val="100000"/>
-              </a:lnSpc>
-              <a:buNone/>
-            </a:pPr>
-            <a:r>
-              <a:rPr lang="en-US" sz="1900" b="1" dirty="0">
-                <a:solidFill>
-                  <a:srgbClr val="2E7D5B"/>
-                </a:solidFill>
-                <a:latin typeface="Calibri" pitchFamily="34" charset="0"/>
-                <a:ea typeface="Calibri" pitchFamily="34" charset="-122"/>
-                <a:cs typeface="Calibri" pitchFamily="34" charset="-120"/>
-              </a:rPr>
-              <a:t>Wider band</a:t>
-            </a:r>
-            <a:endParaRPr lang="en-US" sz="1900" dirty="0"/>
-          </a:p>
-        </p:txBody>
-      </p:sp>
-      <p:sp>
-        <p:nvSpPr>
-          <p:cNvPr id="18" name="Text 12"/>
-          <p:cNvSpPr txBox="1"/>
-          <p:nvPr/>
-        </p:nvSpPr>
-        <p:spPr>
-          <a:xfrm>
             <a:off x="6926963" y="2057400"/>
             <a:ext cx="4578932" cy="731520"/>
           </a:xfrm>
@@ -6363,7 +6289,7 @@
       </p:sp>
       <p:sp>
         <p:nvSpPr>
-          <p:cNvPr id="19" name="Shape 13"/>
+          <p:cNvPr id="18" name="Shape 12"/>
           <p:cNvSpPr/>
           <p:nvPr/>
         </p:nvSpPr>
@@ -6385,7 +6311,7 @@
       </p:sp>
       <p:sp>
         <p:nvSpPr>
-          <p:cNvPr id="20" name="Shape 14"/>
+          <p:cNvPr id="19" name="Shape 13"/>
           <p:cNvSpPr/>
           <p:nvPr/>
         </p:nvSpPr>
@@ -6405,7 +6331,7 @@
       </p:sp>
       <p:pic>
         <p:nvPicPr>
-          <p:cNvPr id="21" name="Image 3" descr="preencoded.png">    </p:cNvPr>
+          <p:cNvPr id="20" name="Image 3" descr="preencoded.png">    </p:cNvPr>
           <p:cNvPicPr>
             <a:picLocks noChangeAspect="1"/>
           </p:cNvPicPr>
@@ -6429,54 +6355,54 @@
       </p:pic>
       <p:sp>
         <p:nvSpPr>
+          <p:cNvPr id="21" name="Text 14"/>
+          <p:cNvSpPr txBox="1"/>
+          <p:nvPr/>
+        </p:nvSpPr>
+        <p:spPr>
+          <a:xfrm>
+            <a:off x="6926963" y="3154680"/>
+            <a:ext cx="4578932" cy="411480"/>
+          </a:xfrm>
+          <a:prstGeom prst="rect">
+            <a:avLst/>
+          </a:prstGeom>
+          <a:noFill/>
+          <a:ln/>
+        </p:spPr>
+        <p:txBody>
+          <a:bodyPr wrap="square" lIns="0" tIns="0" rIns="0" bIns="0" rtlCol="0" anchor="t"/>
+          <a:lstStyle/>
+          <a:p>
+            <a:pPr algn="l" indent="0" marL="0">
+              <a:lnSpc>
+                <a:spcPct val="100000"/>
+              </a:lnSpc>
+              <a:buNone/>
+            </a:pPr>
+            <a:r>
+              <a:rPr lang="en-US" sz="1900" b="1" dirty="0">
+                <a:solidFill>
+                  <a:srgbClr val="C0392B"/>
+                </a:solidFill>
+                <a:latin typeface="Calibri" pitchFamily="34" charset="0"/>
+                <a:ea typeface="Calibri" pitchFamily="34" charset="-122"/>
+                <a:cs typeface="Calibri" pitchFamily="34" charset="-120"/>
+              </a:rPr>
+              <a:t>3 narrow gaps</a:t>
+            </a:r>
+            <a:endParaRPr lang="en-US" sz="1900" dirty="0"/>
+          </a:p>
+        </p:txBody>
+      </p:sp>
+      <p:sp>
+        <p:nvSpPr>
           <p:cNvPr id="22" name="Text 15"/>
           <p:cNvSpPr txBox="1"/>
           <p:nvPr/>
         </p:nvSpPr>
         <p:spPr>
           <a:xfrm>
-            <a:off x="6926963" y="3154680"/>
-            <a:ext cx="4578932" cy="411480"/>
-          </a:xfrm>
-          <a:prstGeom prst="rect">
-            <a:avLst/>
-          </a:prstGeom>
-          <a:noFill/>
-          <a:ln/>
-        </p:spPr>
-        <p:txBody>
-          <a:bodyPr wrap="square" lIns="0" tIns="0" rIns="0" bIns="0" rtlCol="0" anchor="t"/>
-          <a:lstStyle/>
-          <a:p>
-            <a:pPr algn="l" indent="0" marL="0">
-              <a:lnSpc>
-                <a:spcPct val="100000"/>
-              </a:lnSpc>
-              <a:buNone/>
-            </a:pPr>
-            <a:r>
-              <a:rPr lang="en-US" sz="1900" b="1" dirty="0">
-                <a:solidFill>
-                  <a:srgbClr val="C0392B"/>
-                </a:solidFill>
-                <a:latin typeface="Calibri" pitchFamily="34" charset="0"/>
-                <a:ea typeface="Calibri" pitchFamily="34" charset="-122"/>
-                <a:cs typeface="Calibri" pitchFamily="34" charset="-120"/>
-              </a:rPr>
-              <a:t>3 narrow gaps</a:t>
-            </a:r>
-            <a:endParaRPr lang="en-US" sz="1900" dirty="0"/>
-          </a:p>
-        </p:txBody>
-      </p:sp>
-      <p:sp>
-        <p:nvSpPr>
-          <p:cNvPr id="23" name="Text 16"/>
-          <p:cNvSpPr txBox="1"/>
-          <p:nvPr/>
-        </p:nvSpPr>
-        <p:spPr>
-          <a:xfrm>
             <a:off x="6926963" y="3566160"/>
             <a:ext cx="4578932" cy="731520"/>
           </a:xfrm>
@@ -6533,7 +6459,7 @@
       </p:sp>
       <p:sp>
         <p:nvSpPr>
-          <p:cNvPr id="24" name="Shape 17"/>
+          <p:cNvPr id="23" name="Shape 16"/>
           <p:cNvSpPr/>
           <p:nvPr/>
         </p:nvSpPr>
@@ -6555,7 +6481,7 @@
       </p:sp>
       <p:sp>
         <p:nvSpPr>
-          <p:cNvPr id="25" name="Shape 18"/>
+          <p:cNvPr id="24" name="Shape 17"/>
           <p:cNvSpPr/>
           <p:nvPr/>
         </p:nvSpPr>
@@ -6575,7 +6501,7 @@
       </p:sp>
       <p:pic>
         <p:nvPicPr>
-          <p:cNvPr id="26" name="Image 4" descr="preencoded.png">    </p:cNvPr>
+          <p:cNvPr id="25" name="Image 4" descr="preencoded.png">    </p:cNvPr>
           <p:cNvPicPr>
             <a:picLocks noChangeAspect="1"/>
           </p:cNvPicPr>
@@ -6599,14 +6525,56 @@
       </p:pic>
       <p:sp>
         <p:nvSpPr>
+          <p:cNvPr id="26" name="Text 18"/>
+          <p:cNvSpPr txBox="1"/>
+          <p:nvPr/>
+        </p:nvSpPr>
+        <p:spPr>
+          <a:xfrm>
+            <a:off x="6926963" y="4663440"/>
+            <a:ext cx="4578932" cy="411480"/>
+          </a:xfrm>
+          <a:prstGeom prst="rect">
+            <a:avLst/>
+          </a:prstGeom>
+          <a:noFill/>
+          <a:ln/>
+        </p:spPr>
+        <p:txBody>
+          <a:bodyPr wrap="square" lIns="0" tIns="0" rIns="0" bIns="0" rtlCol="0" anchor="t"/>
+          <a:lstStyle/>
+          <a:p>
+            <a:pPr algn="l" indent="0" marL="0">
+              <a:lnSpc>
+                <a:spcPct val="100000"/>
+              </a:lnSpc>
+              <a:buNone/>
+            </a:pPr>
+            <a:r>
+              <a:rPr lang="en-US" sz="1900" b="1" dirty="0">
+                <a:solidFill>
+                  <a:srgbClr val="B8651B"/>
+                </a:solidFill>
+                <a:latin typeface="Calibri" pitchFamily="34" charset="0"/>
+                <a:ea typeface="Calibri" pitchFamily="34" charset="-122"/>
+                <a:cs typeface="Calibri" pitchFamily="34" charset="-120"/>
+              </a:rPr>
+              <a:t>Next: tune</a:t>
+            </a:r>
+            <a:endParaRPr lang="en-US" sz="1900" dirty="0"/>
+          </a:p>
+        </p:txBody>
+      </p:sp>
+      <p:sp>
+        <p:nvSpPr>
           <p:cNvPr id="27" name="Text 19"/>
           <p:cNvSpPr txBox="1"/>
           <p:nvPr/>
         </p:nvSpPr>
         <p:spPr>
           <a:xfrm>
-            <a:off x="6926963" y="4663440"/>
-            <a:ext cx="4578932" cy="411480"/>
+            <a:off x="6926963" y="5074920"/>
+            <a:ext cx="4578932" cy="731520"/>
           </a:xfrm>
           <a:prstGeom prst="rect">
             <a:avLst/>
@@ -6625,17 +6593,17 @@
               <a:buNone/>
             </a:pPr>
             <a:r>
-              <a:rPr lang="en-US" sz="1900" b="1" dirty="0">
-                <a:solidFill>
-                  <a:srgbClr val="B8651B"/>
-                </a:solidFill>
-                <a:latin typeface="Calibri" pitchFamily="34" charset="0"/>
-                <a:ea typeface="Calibri" pitchFamily="34" charset="-122"/>
-                <a:cs typeface="Calibri" pitchFamily="34" charset="-120"/>
-              </a:rPr>
-              <a:t>Next: tune</a:t>
-            </a:r>
-            <a:endParaRPr lang="en-US" sz="1900" dirty="0"/>
+              <a:rPr lang="en-US" sz="1500" dirty="0">
+                <a:solidFill>
+                  <a:srgbClr val="1F2328"/>
+                </a:solidFill>
+                <a:latin typeface="Calibri" pitchFamily="34" charset="0"/>
+                <a:ea typeface="Calibri" pitchFamily="34" charset="-122"/>
+                <a:cs typeface="Calibri" pitchFamily="34" charset="-120"/>
+              </a:rPr>
+              <a:t>air gap, ring size and ground position</a:t>
+            </a:r>
+            <a:endParaRPr lang="en-US" sz="1500" dirty="0"/>
           </a:p>
         </p:txBody>
       </p:sp>
@@ -6647,48 +6615,6 @@
         </p:nvSpPr>
         <p:spPr>
           <a:xfrm>
-            <a:off x="6926963" y="5074920"/>
-            <a:ext cx="4578932" cy="731520"/>
-          </a:xfrm>
-          <a:prstGeom prst="rect">
-            <a:avLst/>
-          </a:prstGeom>
-          <a:noFill/>
-          <a:ln/>
-        </p:spPr>
-        <p:txBody>
-          <a:bodyPr wrap="square" lIns="0" tIns="0" rIns="0" bIns="0" rtlCol="0" anchor="t"/>
-          <a:lstStyle/>
-          <a:p>
-            <a:pPr algn="l" indent="0" marL="0">
-              <a:lnSpc>
-                <a:spcPct val="100000"/>
-              </a:lnSpc>
-              <a:buNone/>
-            </a:pPr>
-            <a:r>
-              <a:rPr lang="en-US" sz="1500" dirty="0">
-                <a:solidFill>
-                  <a:srgbClr val="1F2328"/>
-                </a:solidFill>
-                <a:latin typeface="Calibri" pitchFamily="34" charset="0"/>
-                <a:ea typeface="Calibri" pitchFamily="34" charset="-122"/>
-                <a:cs typeface="Calibri" pitchFamily="34" charset="-120"/>
-              </a:rPr>
-              <a:t>air gap, ring size and ground position</a:t>
-            </a:r>
-            <a:endParaRPr lang="en-US" sz="1500" dirty="0"/>
-          </a:p>
-        </p:txBody>
-      </p:sp>
-      <p:sp>
-        <p:nvSpPr>
-          <p:cNvPr id="29" name="Text 21"/>
-          <p:cNvSpPr txBox="1"/>
-          <p:nvPr/>
-        </p:nvSpPr>
-        <p:spPr>
-          <a:xfrm>
             <a:off x="5966843" y="6007608"/>
             <a:ext cx="5676212" cy="274320"/>
           </a:xfrm>
@@ -6720,6 +6646,36 @@
               <a:t>18 GHz is the end of the simulated range · gain not simulated yet</a:t>
             </a:r>
             <a:endParaRPr lang="en-US" sz="1200" dirty="0"/>
+          </a:p>
+        </p:txBody>
+      </p:sp>
+      <p:sp>
+        <p:nvSpPr>
+          <p:cNvPr id="29" name="Text 0"/>
+          <p:cNvSpPr/>
+          <p:nvPr>
+            <p:ph idx="100" type="body" hasCustomPrompt="1"/>
+          </p:nvPr>
+        </p:nvSpPr>
+        <p:spPr>
+          <a:xfrm>
+            <a:off x="548640" y="347472"/>
+            <a:ext cx="8229600" cy="292608"/>
+          </a:xfrm>
+          <a:prstGeom prst="rect">
+            <a:avLst/>
+          </a:prstGeom>
+          <a:noFill/>
+          <a:ln/>
+        </p:spPr>
+        <p:txBody>
+          <a:bodyPr wrap="square" lIns="0" tIns="0" rIns="0" bIns="0" rtlCol="0" anchor="ctr"/>
+          <a:lstStyle/>
+          <a:p>
+            <a:pPr indent="0" marL="0">
+              <a:buNone/>
+            </a:pPr>
+            <a:endParaRPr lang="en-US" sz="1300" dirty="0"/>
           </a:p>
         </p:txBody>
       </p:sp>
@@ -6872,7 +6828,7 @@
                 <a:ea typeface="Cambria" pitchFamily="34" charset="-122"/>
                 <a:cs typeface="Cambria" pitchFamily="34" charset="-120"/>
               </a:rPr>
-              <a:t>What was hard, and what comes next</a:t>
+              <a:t>What were the challenges, and what comes next</a:t>
             </a:r>
             <a:endParaRPr lang="en-US" sz="3400" dirty="0"/>
           </a:p>
@@ -8778,7 +8734,7 @@
                 <a:ea typeface="Calibri" pitchFamily="34" charset="-122"/>
                 <a:cs typeface="Calibri" pitchFamily="34" charset="-120"/>
               </a:rPr>
-              <a:t>6 × 5 split rings, 3.9 mm behind: wider band, 3 gaps to tune</a:t>
+              <a:t>6 × 5 split rings, 2 mm behind: wider band, 3 gaps to tune</a:t>
             </a:r>
             <a:endParaRPr lang="en-US" sz="1500" dirty="0"/>
           </a:p>
@@ -14747,7 +14703,7 @@
                 <a:ea typeface="Calibri" pitchFamily="34" charset="-122"/>
                 <a:cs typeface="Calibri" pitchFamily="34" charset="-120"/>
               </a:rPr>
-              <a:t>3.9 mm</a:t>
+              <a:t>2 mm</a:t>
             </a:r>
             <a:endParaRPr lang="en-US" sz="1400" dirty="0"/>
           </a:p>
@@ -15203,7 +15159,7 @@
                 <a:ea typeface="Calibri" pitchFamily="34" charset="-122"/>
                 <a:cs typeface="Calibri" pitchFamily="34" charset="-120"/>
               </a:rPr>
-              <a:t>Placed only 3.9 mm behind → can stay thin</a:t>
+              <a:t>Placed only 2 mm behind → can stay thin</a:t>
             </a:r>
             <a:endParaRPr lang="en-US" sz="1500" dirty="0"/>
           </a:p>
@@ -18402,7 +18358,7 @@
                           <a:ea typeface="Calibri" pitchFamily="34" charset="-122"/>
                           <a:cs typeface="Calibri" pitchFamily="34" charset="-120"/>
                         </a:rPr>
-                        <a:t>3.9 mm</a:t>
+                        <a:t>2 mm</a:t>
                       </a:r>
                       <a:endParaRPr lang="en-US" sz="1400" dirty="0">
                         <a:latin typeface="Calibri" charset="0"/>
@@ -18709,7 +18665,7 @@
                 <a:ea typeface="Calibri" pitchFamily="34" charset="-122"/>
                 <a:cs typeface="Calibri" pitchFamily="34" charset="-120"/>
               </a:rPr>
-              <a:t>A metasurface only about 4 mm behind an antenna that works from about 2 to 15 GHz is rarely reported → our aim: 3.9 mm, then MIMO</a:t>
+              <a:t>A metasurface only a few mm behind an antenna that works from about 2 to 15 GHz is rarely reported → our aim: 2 mm, then MIMO</a:t>
             </a:r>
             <a:endParaRPr lang="en-US" sz="1500" dirty="0"/>
           </a:p>

</xml_diff>